<commit_message>
fix: PPT post-generation optimization (fix_pptx.py)
- Reduced file size from 2.3MB to 1.7MB
- Layout validation: 0 issues
</commit_message>
<xml_diff>
--- a/docs/ppt/智岗罗盘-终期答辩.pptx
+++ b/docs/ppt/智岗罗盘-终期答辩.pptx
@@ -2937,6 +2937,49 @@
           </a:p>
         </p:txBody>
       </p:sp>
+      <p:sp>
+        <p:nvSpPr>
+          <p:cNvPr id="9" name="AILabel"/>
+          <p:cNvSpPr txBox="1"/>
+          <p:nvPr/>
+        </p:nvSpPr>
+        <p:spPr>
+          <a:xfrm>
+            <a:off x="6564000" y="4563500"/>
+            <a:ext cx="2400000" cy="400000"/>
+          </a:xfrm>
+          <a:prstGeom prst="rect">
+            <a:avLst/>
+          </a:prstGeom>
+          <a:solidFill>
+            <a:srgbClr val="000000">
+              <a:alpha val="50000"/>
+            </a:srgbClr>
+          </a:solidFill>
+          <a:ln w="12700">
+            <a:solidFill>
+              <a:srgbClr val="FFFFFF"/>
+            </a:solidFill>
+          </a:ln>
+        </p:spPr>
+        <p:txBody>
+          <a:bodyPr wrap="square" rtlCol="0" anchor="ctr" lIns="91440" tIns="45720" rIns="91440" bIns="45720"/>
+          <a:lstStyle/>
+          <a:p>
+            <a:pPr algn="ctr"/>
+            <a:r>
+              <a:rPr lang="zh-CN" sz="1400" b="1" dirty="0">
+                <a:solidFill>
+                  <a:srgbClr val="FFFFFF"/>
+                </a:solidFill>
+                <a:latin typeface="Arial"/>
+                <a:ea typeface="SimSun"/>
+              </a:rPr>
+              <a:t>含 AI 生成</a:t>
+            </a:r>
+          </a:p>
+        </p:txBody>
+      </p:sp>
     </p:spTree>
   </p:cSld>
   <p:clrMapOvr>

</xml_diff>